<commit_message>
Fix logo layout on frameworks slide
</commit_message>
<xml_diff>
--- a/machine_learning_with_python.pptx
+++ b/machine_learning_with_python.pptx
@@ -348,7 +348,7 @@
           <a:p>
             <a:fld id="{DBF5F7A3-80FA-4DE8-9E10-D5FD6AAF4E4C}" type="datetimeFigureOut">
               <a:rPr lang="en-US" smtClean="0"/>
-              <a:t>2025-01-13</a:t>
+              <a:t>2026-01-12</a:t>
             </a:fld>
             <a:endParaRPr lang="en-US"/>
           </a:p>
@@ -902,7 +902,7 @@
           <a:p>
             <a:fld id="{12D417FB-DB75-4510-8AD7-5416595AADD8}" type="datetime1">
               <a:rPr lang="en-US" smtClean="0"/>
-              <a:t>2025-01-13</a:t>
+              <a:t>2026-01-12</a:t>
             </a:fld>
             <a:endParaRPr lang="en-US"/>
           </a:p>
@@ -3270,7 +3270,7 @@
           <a:p>
             <a:fld id="{EC448E59-F64F-416B-85C7-F58EA54BAF31}" type="datetime1">
               <a:rPr lang="nl-BE" smtClean="0"/>
-              <a:t>13/01/2025</a:t>
+              <a:t>12/01/2026</a:t>
             </a:fld>
             <a:endParaRPr lang="nl-BE"/>
           </a:p>
@@ -3516,7 +3516,7 @@
           <a:p>
             <a:fld id="{9ED5C3B5-60AD-4494-9CFA-8B02B158E887}" type="datetime1">
               <a:rPr lang="nl-BE" smtClean="0"/>
-              <a:t>13/01/2025</a:t>
+              <a:t>12/01/2026</a:t>
             </a:fld>
             <a:endParaRPr lang="nl-BE"/>
           </a:p>
@@ -3634,7 +3634,7 @@
           <a:p>
             <a:fld id="{1E4894A8-27B8-4F4D-B345-90FD4A1447E9}" type="datetime1">
               <a:rPr lang="nl-BE" smtClean="0"/>
-              <a:t>13/01/2025</a:t>
+              <a:t>12/01/2026</a:t>
             </a:fld>
             <a:endParaRPr lang="nl-BE"/>
           </a:p>
@@ -3922,7 +3922,7 @@
           <a:p>
             <a:fld id="{44F0EF99-E673-4972-A23A-EB3FD1F7D254}" type="datetime1">
               <a:rPr lang="nl-BE" smtClean="0"/>
-              <a:t>13/01/2025</a:t>
+              <a:t>12/01/2026</a:t>
             </a:fld>
             <a:endParaRPr lang="nl-BE"/>
           </a:p>
@@ -31422,7 +31422,7 @@
         </p:blipFill>
         <p:spPr bwMode="auto">
           <a:xfrm>
-            <a:off x="4937927" y="2944514"/>
+            <a:off x="8051239" y="2617942"/>
             <a:ext cx="2479910" cy="2113560"/>
           </a:xfrm>
           <a:prstGeom prst="rect">

</xml_diff>